<commit_message>
P5 final: new-UI screenshots (9), verified ZIP 8/8 items, checklist 8/8
</commit_message>
<xml_diff>
--- a/Team404_Submission/Team404_Deck.pptx
+++ b/Team404_Submission/Team404_Deck.pptx
@@ -3410,7 +3410,7 @@
               </a:defRPr>
             </a:pPr>
             <a:r>
-              <a:t>• 5-step wizard: Profile → Loss Analysis → Risk → Plan → Ongoing Optimizer</a:t>
+              <a:t>• 5-step wizard: Rich Profile → Loss Analysis → Risk → Plan → Ongoing Optimizer</a:t>
             </a:r>
           </a:p>
           <a:p>
@@ -3425,7 +3425,7 @@
               </a:defRPr>
             </a:pPr>
             <a:r>
-              <a:t>• Every claim proven against REAL market data (yfinance, 12 live tickers)</a:t>
+              <a:t>• Asks what real advice needs: age, income, expenses, dependents, goals, emergency fund</a:t>
             </a:r>
           </a:p>
           <a:p>
@@ -3440,7 +3440,7 @@
               </a:defRPr>
             </a:pPr>
             <a:r>
-              <a:t>• Deterministic AI rule-engine — works offline, cannot crash on API outages</a:t>
+              <a:t>• Every claim proven against REAL market data (yfinance, 12 live tickers)</a:t>
             </a:r>
           </a:p>
           <a:p>
@@ -3455,7 +3455,37 @@
               </a:defRPr>
             </a:pPr>
             <a:r>
-              <a:t>• Experience dial: explanation depth adapts Beginner / Intermediate / Experienced</a:t>
+              <a:t>• Deterministic AI rule-engine — works offline, cannot crash on API outages</a:t>
+            </a:r>
+          </a:p>
+          <a:p>
+            <a:pPr>
+              <a:spcAft>
+                <a:spcPts val="1000"/>
+              </a:spcAft>
+              <a:defRPr sz="2000">
+                <a:solidFill>
+                  <a:srgbClr val="FFFFFF"/>
+                </a:solidFill>
+              </a:defRPr>
+            </a:pPr>
+            <a:r>
+              <a:t>• Advisory rules: 110−age glide path · goal buckets · emergency-fund gate ·</a:t>
+            </a:r>
+          </a:p>
+          <a:p>
+            <a:pPr>
+              <a:spcAft>
+                <a:spcPts val="1000"/>
+              </a:spcAft>
+              <a:defRPr sz="1600">
+                <a:solidFill>
+                  <a:srgbClr val="FFFFFF"/>
+                </a:solidFill>
+              </a:defRPr>
+            </a:pPr>
+            <a:r>
+              <a:t>  risk capacity vs willingness (binding = min)</a:t>
             </a:r>
           </a:p>
           <a:p>
@@ -3599,6 +3629,36 @@
               </a:defRPr>
             </a:pPr>
             <a:r>
+              <a:t>• DUAL PLAN: Recommended-for-you (profile-driven) + Build-your-own (live sliders,</a:t>
+            </a:r>
+          </a:p>
+          <a:p>
+            <a:pPr>
+              <a:spcAft>
+                <a:spcPts val="1000"/>
+              </a:spcAft>
+              <a:defRPr sz="1600">
+                <a:solidFill>
+                  <a:srgbClr val="FFFFFF"/>
+                </a:solidFill>
+              </a:defRPr>
+            </a:pPr>
+            <a:r>
+              <a:t>  expected return vs worst-case trade-off, guard-rail warnings)</a:t>
+            </a:r>
+          </a:p>
+          <a:p>
+            <a:pPr>
+              <a:spcAft>
+                <a:spcPts val="1000"/>
+              </a:spcAft>
+              <a:defRPr sz="2000">
+                <a:solidFill>
+                  <a:srgbClr val="FFFFFF"/>
+                </a:solidFill>
+              </a:defRPr>
+            </a:pPr>
+            <a:r>
               <a:t>• High-risk: aggressive picks w/ live momentum, volatility, drawdown + reasoning</a:t>
             </a:r>
           </a:p>
@@ -3728,7 +3788,7 @@
               </a:defRPr>
             </a:pPr>
             <a:r>
-              <a:t>1. Enter profile: ₹5L, Experienced, held stocks</a:t>
+              <a:t>1. Rich intake: age 28, ₹80k income, goal 12y, risk willingness 4/5, budget ₹1L</a:t>
             </a:r>
           </a:p>
           <a:p>
@@ -3758,7 +3818,7 @@
               </a:defRPr>
             </a:pPr>
             <a:r>
-              <a:t>3. Risk: YES → aggressive plan, 4 live picks, pie allocation</a:t>
+              <a:t>3. Risk: YES → Recommended plan (76% equity, emergency-gate flag) vs Custom sliders</a:t>
             </a:r>
           </a:p>
           <a:p>

</xml_diff>